<commit_message>
last update to presentation
</commit_message>
<xml_diff>
--- a/concept/SeminarPresentation26Q2.pptx
+++ b/concept/SeminarPresentation26Q2.pptx
@@ -5,7 +5,7 @@
     <p:sldMasterId id="2147483648" r:id="rId1"/>
   </p:sldMasterIdLst>
   <p:notesMasterIdLst>
-    <p:notesMasterId r:id="rId27"/>
+    <p:notesMasterId r:id="rId28"/>
   </p:notesMasterIdLst>
   <p:sldIdLst>
     <p:sldId id="291" r:id="rId2"/>
@@ -28,11 +28,12 @@
     <p:sldId id="319" r:id="rId19"/>
     <p:sldId id="320" r:id="rId20"/>
     <p:sldId id="321" r:id="rId21"/>
-    <p:sldId id="322" r:id="rId22"/>
-    <p:sldId id="323" r:id="rId23"/>
-    <p:sldId id="306" r:id="rId24"/>
-    <p:sldId id="307" r:id="rId25"/>
-    <p:sldId id="294" r:id="rId26"/>
+    <p:sldId id="324" r:id="rId22"/>
+    <p:sldId id="322" r:id="rId23"/>
+    <p:sldId id="323" r:id="rId24"/>
+    <p:sldId id="306" r:id="rId25"/>
+    <p:sldId id="307" r:id="rId26"/>
+    <p:sldId id="294" r:id="rId27"/>
   </p:sldIdLst>
   <p:sldSz cx="12192000" cy="6858000"/>
   <p:notesSz cx="6858000" cy="9144000"/>
@@ -12750,6 +12751,413 @@
   <p:cSld>
     <p:spTree>
       <p:nvGrpSpPr>
+        <p:cNvPr id="1" name="">
+          <a:extLst>
+            <a:ext uri="{FF2B5EF4-FFF2-40B4-BE49-F238E27FC236}">
+              <a16:creationId xmlns:a16="http://schemas.microsoft.com/office/drawing/2014/main" id="{5DFC9938-621D-0022-6E96-69EE6496D36B}"/>
+            </a:ext>
+          </a:extLst>
+        </p:cNvPr>
+        <p:cNvGrpSpPr/>
+        <p:nvPr/>
+      </p:nvGrpSpPr>
+      <p:grpSpPr>
+        <a:xfrm>
+          <a:off x="0" y="0"/>
+          <a:ext cx="0" cy="0"/>
+          <a:chOff x="0" y="0"/>
+          <a:chExt cx="0" cy="0"/>
+        </a:xfrm>
+      </p:grpSpPr>
+      <p:sp>
+        <p:nvSpPr>
+          <p:cNvPr id="2" name="Title 1">
+            <a:extLst>
+              <a:ext uri="{FF2B5EF4-FFF2-40B4-BE49-F238E27FC236}">
+                <a16:creationId xmlns:a16="http://schemas.microsoft.com/office/drawing/2014/main" id="{ABF3F4D7-BD7D-D4CD-9A91-3263D36F1091}"/>
+              </a:ext>
+            </a:extLst>
+          </p:cNvPr>
+          <p:cNvSpPr>
+            <a:spLocks noGrp="1"/>
+          </p:cNvSpPr>
+          <p:nvPr>
+            <p:ph type="title"/>
+          </p:nvPr>
+        </p:nvSpPr>
+        <p:spPr/>
+        <p:txBody>
+          <a:bodyPr/>
+          <a:lstStyle/>
+          <a:p>
+            <a:r>
+              <a:rPr lang="en-GB"/>
+              <a:t>Static Analysis via Backtranslation</a:t>
+            </a:r>
+            <a:endParaRPr lang="en-US"/>
+          </a:p>
+        </p:txBody>
+      </p:sp>
+      <p:sp>
+        <p:nvSpPr>
+          <p:cNvPr id="4" name="Slide Number Placeholder 3">
+            <a:extLst>
+              <a:ext uri="{FF2B5EF4-FFF2-40B4-BE49-F238E27FC236}">
+                <a16:creationId xmlns:a16="http://schemas.microsoft.com/office/drawing/2014/main" id="{004D86CA-3AD8-2205-C016-FC5D53786826}"/>
+              </a:ext>
+            </a:extLst>
+          </p:cNvPr>
+          <p:cNvSpPr>
+            <a:spLocks noGrp="1"/>
+          </p:cNvSpPr>
+          <p:nvPr>
+            <p:ph type="sldNum" sz="quarter" idx="12"/>
+          </p:nvPr>
+        </p:nvSpPr>
+        <p:spPr/>
+        <p:txBody>
+          <a:bodyPr/>
+          <a:lstStyle/>
+          <a:p>
+            <a:fld id="{52890E68-D690-4AC2-96FA-C0B5F80968DC}" type="slidenum">
+              <a:rPr lang="en-US" smtClean="0"/>
+              <a:t>21</a:t>
+            </a:fld>
+            <a:endParaRPr lang="en-US"/>
+          </a:p>
+        </p:txBody>
+      </p:sp>
+      <p:sp>
+        <p:nvSpPr>
+          <p:cNvPr id="5" name="Text Placeholder 4">
+            <a:extLst>
+              <a:ext uri="{FF2B5EF4-FFF2-40B4-BE49-F238E27FC236}">
+                <a16:creationId xmlns:a16="http://schemas.microsoft.com/office/drawing/2014/main" id="{B92C6EDE-6B55-2CE2-5CD1-1078859D2D99}"/>
+              </a:ext>
+            </a:extLst>
+          </p:cNvPr>
+          <p:cNvSpPr>
+            <a:spLocks noGrp="1"/>
+          </p:cNvSpPr>
+          <p:nvPr>
+            <p:ph type="body" sz="quarter" idx="13"/>
+          </p:nvPr>
+        </p:nvSpPr>
+        <p:spPr/>
+        <p:txBody>
+          <a:bodyPr/>
+          <a:lstStyle/>
+          <a:p>
+            <a:r>
+              <a:rPr lang="en-GB"/>
+              <a:t>Proposal</a:t>
+            </a:r>
+            <a:endParaRPr lang="en-US"/>
+          </a:p>
+        </p:txBody>
+      </p:sp>
+      <p:sp>
+        <p:nvSpPr>
+          <p:cNvPr id="3" name="Rectangle: Rounded Corners 2">
+            <a:extLst>
+              <a:ext uri="{FF2B5EF4-FFF2-40B4-BE49-F238E27FC236}">
+                <a16:creationId xmlns:a16="http://schemas.microsoft.com/office/drawing/2014/main" id="{1BACC8FB-61F6-F44F-2C24-0EEAEBECAEC5}"/>
+              </a:ext>
+            </a:extLst>
+          </p:cNvPr>
+          <p:cNvSpPr/>
+          <p:nvPr/>
+        </p:nvSpPr>
+        <p:spPr>
+          <a:xfrm>
+            <a:off x="838200" y="2718352"/>
+            <a:ext cx="2196547" cy="2136913"/>
+          </a:xfrm>
+          <a:prstGeom prst="roundRect">
+            <a:avLst/>
+          </a:prstGeom>
+          <a:solidFill>
+            <a:schemeClr val="tx2">
+              <a:lumMod val="90000"/>
+              <a:lumOff val="10000"/>
+            </a:schemeClr>
+          </a:solidFill>
+          <a:ln w="19050" cap="flat" cmpd="sng" algn="ctr">
+            <a:solidFill>
+              <a:srgbClr val="0070C0"/>
+            </a:solidFill>
+            <a:prstDash val="solid"/>
+            <a:round/>
+            <a:headEnd type="none" w="med" len="med"/>
+            <a:tailEnd type="arrow" w="med" len="med"/>
+          </a:ln>
+        </p:spPr>
+        <p:style>
+          <a:lnRef idx="0">
+            <a:scrgbClr r="0" g="0" b="0"/>
+          </a:lnRef>
+          <a:fillRef idx="0">
+            <a:scrgbClr r="0" g="0" b="0"/>
+          </a:fillRef>
+          <a:effectRef idx="0">
+            <a:scrgbClr r="0" g="0" b="0"/>
+          </a:effectRef>
+          <a:fontRef idx="minor">
+            <a:schemeClr val="tx1"/>
+          </a:fontRef>
+        </p:style>
+        <p:txBody>
+          <a:bodyPr rtlCol="0" anchor="ctr"/>
+          <a:lstStyle/>
+          <a:p>
+            <a:pPr algn="ctr"/>
+            <a:r>
+              <a:rPr lang="en-GB" sz="2000">
+                <a:solidFill>
+                  <a:schemeClr val="bg1"/>
+                </a:solidFill>
+              </a:rPr>
+              <a:t>1. Find embedded language code</a:t>
+            </a:r>
+            <a:endParaRPr lang="en-US" sz="2000">
+              <a:solidFill>
+                <a:schemeClr val="bg1"/>
+              </a:solidFill>
+            </a:endParaRPr>
+          </a:p>
+        </p:txBody>
+      </p:sp>
+      <p:sp>
+        <p:nvSpPr>
+          <p:cNvPr id="13" name="Rectangle: Rounded Corners 12">
+            <a:extLst>
+              <a:ext uri="{FF2B5EF4-FFF2-40B4-BE49-F238E27FC236}">
+                <a16:creationId xmlns:a16="http://schemas.microsoft.com/office/drawing/2014/main" id="{FA1C7412-1CE0-9660-2C60-FD984DF65EC9}"/>
+              </a:ext>
+            </a:extLst>
+          </p:cNvPr>
+          <p:cNvSpPr/>
+          <p:nvPr/>
+        </p:nvSpPr>
+        <p:spPr>
+          <a:xfrm>
+            <a:off x="3700758" y="2718351"/>
+            <a:ext cx="2196547" cy="2136913"/>
+          </a:xfrm>
+          <a:prstGeom prst="roundRect">
+            <a:avLst/>
+          </a:prstGeom>
+          <a:solidFill>
+            <a:schemeClr val="tx2">
+              <a:lumMod val="90000"/>
+              <a:lumOff val="10000"/>
+            </a:schemeClr>
+          </a:solidFill>
+          <a:ln w="19050" cap="flat" cmpd="sng" algn="ctr">
+            <a:solidFill>
+              <a:srgbClr val="0070C0"/>
+            </a:solidFill>
+            <a:prstDash val="solid"/>
+            <a:round/>
+            <a:headEnd type="none" w="med" len="med"/>
+            <a:tailEnd type="arrow" w="med" len="med"/>
+          </a:ln>
+        </p:spPr>
+        <p:style>
+          <a:lnRef idx="0">
+            <a:scrgbClr r="0" g="0" b="0"/>
+          </a:lnRef>
+          <a:fillRef idx="0">
+            <a:scrgbClr r="0" g="0" b="0"/>
+          </a:fillRef>
+          <a:effectRef idx="0">
+            <a:scrgbClr r="0" g="0" b="0"/>
+          </a:effectRef>
+          <a:fontRef idx="minor">
+            <a:schemeClr val="tx1"/>
+          </a:fontRef>
+        </p:style>
+        <p:txBody>
+          <a:bodyPr rtlCol="0" anchor="ctr"/>
+          <a:lstStyle/>
+          <a:p>
+            <a:pPr algn="ctr"/>
+            <a:r>
+              <a:rPr lang="en-GB" sz="2000">
+                <a:solidFill>
+                  <a:schemeClr val="bg1"/>
+                </a:solidFill>
+              </a:rPr>
+              <a:t>2. Translate to original DSL</a:t>
+            </a:r>
+            <a:endParaRPr lang="en-US" sz="2000">
+              <a:solidFill>
+                <a:schemeClr val="bg1"/>
+              </a:solidFill>
+            </a:endParaRPr>
+          </a:p>
+        </p:txBody>
+      </p:sp>
+      <p:sp>
+        <p:nvSpPr>
+          <p:cNvPr id="18" name="Rectangle: Rounded Corners 17">
+            <a:extLst>
+              <a:ext uri="{FF2B5EF4-FFF2-40B4-BE49-F238E27FC236}">
+                <a16:creationId xmlns:a16="http://schemas.microsoft.com/office/drawing/2014/main" id="{8D574B53-5E1D-3C33-F772-039DD308024B}"/>
+              </a:ext>
+            </a:extLst>
+          </p:cNvPr>
+          <p:cNvSpPr/>
+          <p:nvPr/>
+        </p:nvSpPr>
+        <p:spPr>
+          <a:xfrm>
+            <a:off x="6563316" y="2718350"/>
+            <a:ext cx="2196547" cy="2136913"/>
+          </a:xfrm>
+          <a:prstGeom prst="roundRect">
+            <a:avLst/>
+          </a:prstGeom>
+          <a:solidFill>
+            <a:schemeClr val="tx2">
+              <a:lumMod val="90000"/>
+              <a:lumOff val="10000"/>
+            </a:schemeClr>
+          </a:solidFill>
+          <a:ln w="19050" cap="flat" cmpd="sng" algn="ctr">
+            <a:solidFill>
+              <a:srgbClr val="0070C0"/>
+            </a:solidFill>
+            <a:prstDash val="solid"/>
+            <a:round/>
+            <a:headEnd type="none" w="med" len="med"/>
+            <a:tailEnd type="arrow" w="med" len="med"/>
+          </a:ln>
+        </p:spPr>
+        <p:style>
+          <a:lnRef idx="0">
+            <a:scrgbClr r="0" g="0" b="0"/>
+          </a:lnRef>
+          <a:fillRef idx="0">
+            <a:scrgbClr r="0" g="0" b="0"/>
+          </a:fillRef>
+          <a:effectRef idx="0">
+            <a:scrgbClr r="0" g="0" b="0"/>
+          </a:effectRef>
+          <a:fontRef idx="minor">
+            <a:schemeClr val="tx1"/>
+          </a:fontRef>
+        </p:style>
+        <p:txBody>
+          <a:bodyPr rtlCol="0" anchor="ctr"/>
+          <a:lstStyle/>
+          <a:p>
+            <a:pPr algn="ctr"/>
+            <a:r>
+              <a:rPr lang="en-GB" sz="2000">
+                <a:solidFill>
+                  <a:schemeClr val="bg1"/>
+                </a:solidFill>
+              </a:rPr>
+              <a:t>3. Analyze w/ existing tools</a:t>
+            </a:r>
+            <a:endParaRPr lang="en-US" sz="2000">
+              <a:solidFill>
+                <a:schemeClr val="bg1"/>
+              </a:solidFill>
+            </a:endParaRPr>
+          </a:p>
+        </p:txBody>
+      </p:sp>
+      <p:sp>
+        <p:nvSpPr>
+          <p:cNvPr id="20" name="Rectangle: Rounded Corners 19">
+            <a:extLst>
+              <a:ext uri="{FF2B5EF4-FFF2-40B4-BE49-F238E27FC236}">
+                <a16:creationId xmlns:a16="http://schemas.microsoft.com/office/drawing/2014/main" id="{6EB62956-AF09-0936-FFAA-49B3EEA1C4BA}"/>
+              </a:ext>
+            </a:extLst>
+          </p:cNvPr>
+          <p:cNvSpPr/>
+          <p:nvPr/>
+        </p:nvSpPr>
+        <p:spPr>
+          <a:xfrm>
+            <a:off x="9425874" y="2718350"/>
+            <a:ext cx="2196547" cy="2136913"/>
+          </a:xfrm>
+          <a:prstGeom prst="roundRect">
+            <a:avLst/>
+          </a:prstGeom>
+          <a:solidFill>
+            <a:schemeClr val="tx2">
+              <a:lumMod val="90000"/>
+              <a:lumOff val="10000"/>
+            </a:schemeClr>
+          </a:solidFill>
+          <a:ln w="19050" cap="flat" cmpd="sng" algn="ctr">
+            <a:solidFill>
+              <a:srgbClr val="0070C0"/>
+            </a:solidFill>
+            <a:prstDash val="solid"/>
+            <a:round/>
+            <a:headEnd type="none" w="med" len="med"/>
+            <a:tailEnd type="arrow" w="med" len="med"/>
+          </a:ln>
+        </p:spPr>
+        <p:style>
+          <a:lnRef idx="0">
+            <a:scrgbClr r="0" g="0" b="0"/>
+          </a:lnRef>
+          <a:fillRef idx="0">
+            <a:scrgbClr r="0" g="0" b="0"/>
+          </a:fillRef>
+          <a:effectRef idx="0">
+            <a:scrgbClr r="0" g="0" b="0"/>
+          </a:effectRef>
+          <a:fontRef idx="minor">
+            <a:schemeClr val="tx1"/>
+          </a:fontRef>
+        </p:style>
+        <p:txBody>
+          <a:bodyPr rtlCol="0" anchor="ctr"/>
+          <a:lstStyle/>
+          <a:p>
+            <a:pPr algn="ctr"/>
+            <a:r>
+              <a:rPr lang="en-GB" sz="2000">
+                <a:solidFill>
+                  <a:schemeClr val="bg1"/>
+                </a:solidFill>
+              </a:rPr>
+              <a:t>4. Project results onto input</a:t>
+            </a:r>
+            <a:endParaRPr lang="en-US" sz="2000">
+              <a:solidFill>
+                <a:schemeClr val="bg1"/>
+              </a:solidFill>
+            </a:endParaRPr>
+          </a:p>
+        </p:txBody>
+      </p:sp>
+    </p:spTree>
+    <p:extLst>
+      <p:ext uri="{BB962C8B-B14F-4D97-AF65-F5344CB8AC3E}">
+        <p14:creationId xmlns:p14="http://schemas.microsoft.com/office/powerpoint/2010/main" val="3838753286"/>
+      </p:ext>
+    </p:extLst>
+  </p:cSld>
+  <p:clrMapOvr>
+    <a:masterClrMapping/>
+  </p:clrMapOvr>
+</p:sld>
+</file>
+
+<file path=ppt/slides/slide22.xml><?xml version="1.0" encoding="utf-8"?>
+<p:sld xmlns:a="http://schemas.openxmlformats.org/drawingml/2006/main" xmlns:r="http://schemas.openxmlformats.org/officeDocument/2006/relationships" xmlns:p="http://schemas.openxmlformats.org/presentationml/2006/main">
+  <p:cSld>
+    <p:spTree>
+      <p:nvGrpSpPr>
         <p:cNvPr id="1" name=""/>
         <p:cNvGrpSpPr/>
         <p:nvPr/>
@@ -12850,7 +13258,7 @@
           <a:p>
             <a:fld id="{52890E68-D690-4AC2-96FA-C0B5F80968DC}" type="slidenum">
               <a:rPr lang="en-US" smtClean="0"/>
-              <a:t>21</a:t>
+              <a:t>22</a:t>
             </a:fld>
             <a:endParaRPr lang="en-US"/>
           </a:p>
@@ -12898,7 +13306,7 @@
 </p:sld>
 </file>
 
-<file path=ppt/slides/slide22.xml><?xml version="1.0" encoding="utf-8"?>
+<file path=ppt/slides/slide23.xml><?xml version="1.0" encoding="utf-8"?>
 <p:sld xmlns:a="http://schemas.openxmlformats.org/drawingml/2006/main" xmlns:r="http://schemas.openxmlformats.org/officeDocument/2006/relationships" xmlns:p="http://schemas.openxmlformats.org/presentationml/2006/main">
   <p:cSld>
     <p:spTree>
@@ -12973,7 +13381,7 @@
           <a:p>
             <a:fld id="{52890E68-D690-4AC2-96FA-C0B5F80968DC}" type="slidenum">
               <a:rPr lang="en-US" smtClean="0"/>
-              <a:t>22</a:t>
+              <a:t>23</a:t>
             </a:fld>
             <a:endParaRPr lang="en-US"/>
           </a:p>
@@ -13534,7 +13942,7 @@
 </p:sld>
 </file>
 
-<file path=ppt/slides/slide23.xml><?xml version="1.0" encoding="utf-8"?>
+<file path=ppt/slides/slide24.xml><?xml version="1.0" encoding="utf-8"?>
 <p:sld xmlns:a="http://schemas.openxmlformats.org/drawingml/2006/main" xmlns:r="http://schemas.openxmlformats.org/officeDocument/2006/relationships" xmlns:p="http://schemas.openxmlformats.org/presentationml/2006/main">
   <p:cSld>
     <p:spTree>
@@ -13655,7 +14063,7 @@
           <a:p>
             <a:fld id="{52890E68-D690-4AC2-96FA-C0B5F80968DC}" type="slidenum">
               <a:rPr lang="en-US" smtClean="0"/>
-              <a:t>23</a:t>
+              <a:t>24</a:t>
             </a:fld>
             <a:endParaRPr lang="en-US"/>
           </a:p>
@@ -13699,7 +14107,7 @@
 </p:sld>
 </file>
 
-<file path=ppt/slides/slide24.xml><?xml version="1.0" encoding="utf-8"?>
+<file path=ppt/slides/slide25.xml><?xml version="1.0" encoding="utf-8"?>
 <p:sld xmlns:a="http://schemas.openxmlformats.org/drawingml/2006/main" xmlns:r="http://schemas.openxmlformats.org/officeDocument/2006/relationships" xmlns:p="http://schemas.openxmlformats.org/presentationml/2006/main">
   <p:cSld>
     <p:spTree>
@@ -13815,7 +14223,7 @@
           <a:p>
             <a:fld id="{52890E68-D690-4AC2-96FA-C0B5F80968DC}" type="slidenum">
               <a:rPr lang="en-US" smtClean="0"/>
-              <a:t>24</a:t>
+              <a:t>25</a:t>
             </a:fld>
             <a:endParaRPr lang="en-US"/>
           </a:p>
@@ -14143,7 +14551,7 @@
 </p:sld>
 </file>
 
-<file path=ppt/slides/slide25.xml><?xml version="1.0" encoding="utf-8"?>
+<file path=ppt/slides/slide26.xml><?xml version="1.0" encoding="utf-8"?>
 <p:sld xmlns:a="http://schemas.openxmlformats.org/drawingml/2006/main" xmlns:r="http://schemas.openxmlformats.org/officeDocument/2006/relationships" xmlns:p="http://schemas.openxmlformats.org/presentationml/2006/main" show="0">
   <p:cSld>
     <p:spTree>
@@ -15198,7 +15606,7 @@
           <a:p>
             <a:fld id="{52890E68-D690-4AC2-96FA-C0B5F80968DC}" type="slidenum">
               <a:rPr lang="en-US" smtClean="0"/>
-              <a:t>25</a:t>
+              <a:t>26</a:t>
             </a:fld>
             <a:endParaRPr lang="en-US"/>
           </a:p>
@@ -19496,7 +19904,7 @@
             </a:pPr>
             <a:r>
               <a:rPr lang="en-GB"/>
-              <a:t>Generate a fluent API where this syntax is encoded in the type system</a:t>
+              <a:t>Generate a fluent API where this syntax is encoded in the type system (Enums + Generics)</a:t>
             </a:r>
             <a:endParaRPr lang="en-US"/>
           </a:p>
@@ -19536,8 +19944,8 @@
           </a:p>
         </p:txBody>
       </p:sp>
-      <mc:AlternateContent xmlns:mc="http://schemas.openxmlformats.org/markup-compatibility/2006" xmlns:a14="http://schemas.microsoft.com/office/drawing/2010/main">
-        <mc:Choice Requires="a14">
+      <mc:AlternateContent xmlns:mc="http://schemas.openxmlformats.org/markup-compatibility/2006">
+        <mc:Choice xmlns:a14="http://schemas.microsoft.com/office/drawing/2010/main" Requires="a14">
           <p:sp>
             <p:nvSpPr>
               <p:cNvPr id="3" name="Content Placeholder 2">
@@ -19854,20 +20262,6 @@
                     </m:oMath>
                   </m:oMathPara>
                 </a14:m>
-                <a:endParaRPr lang="en-GB" sz="2400" b="0">
-                  <a:latin typeface="Consolas" panose="020B0609020204030204" pitchFamily="49" charset="0"/>
-                </a:endParaRPr>
-              </a:p>
-              <a:p>
-                <a:pPr marL="0" indent="0">
-                  <a:buNone/>
-                </a:pPr>
-                <a:endParaRPr lang="en-GB" b="0"/>
-              </a:p>
-              <a:p>
-                <a:pPr marL="0" indent="0">
-                  <a:buNone/>
-                </a:pPr>
                 <a:endParaRPr lang="en-GB" b="0"/>
               </a:p>
               <a:p>
@@ -19879,7 +20273,7 @@
             </p:txBody>
           </p:sp>
         </mc:Choice>
-        <mc:Fallback xmlns="">
+        <mc:Fallback>
           <p:sp>
             <p:nvSpPr>
               <p:cNvPr id="3" name="Content Placeholder 2">
@@ -19904,7 +20298,7 @@
               <a:blipFill>
                 <a:blip r:embed="rId2"/>
                 <a:stretch>
-                  <a:fillRect l="-749" b="-1262"/>
+                  <a:fillRect l="-749" b="-946"/>
                 </a:stretch>
               </a:blipFill>
             </p:spPr>

</xml_diff>